<commit_message>
fix(plantillas): los layouts de la ruta anterior de 8 tipos se escriben desde el estándar (K15)
Texto a la derecha/izquierda, dos gráficos con texto (apilados), asimétrico,
tira, cinco y seis: sus placeholders de plantilla_16_9.pptx toman las
ranuras de estandar_pulso.json. Una sola correspondencia placeholder ↔
ranura (plantilla_layouts_estandar.R), un script que reescribe los layouts
(api/scripts/plantilla_layouts_desde_estandar.R, idempotente) y un test de
conformidad (0.02 in) que además fija el type_idx que officer asigna, para
que cada gráfico caiga en su ranura sin tocar el contrato del motor: en cinco
y seis gráficos el orden del contrato se conserva con un desempate de hasta
0.002 in en y. El ícono del público pasa a la cabecera, como en el recetario.
Sólo cambian esos 8 layouts del .pptx; acrconta: 93 láminas, 0 distintas.
</commit_message>
<xml_diff>
--- a/api/inst/plantillas/plantilla_16_9.pptx
+++ b/api/inst/plantillas/plantilla_16_9.pptx
@@ -1649,8 +1649,8 @@
         </p:nvSpPr>
         <p:spPr>
           <a:xfrm>
-            <a:off x="317501" y="1103243"/>
-            <a:ext cx="5584687" cy="5128593"/>
+            <a:off x="452628" y="1508760"/>
+            <a:ext cx="7863840" cy="4206240"/>
           </a:xfrm>
         </p:spPr>
         <p:txBody>
@@ -1841,8 +1841,8 @@
         </p:nvSpPr>
         <p:spPr>
           <a:xfrm>
-            <a:off x="6173926" y="1103313"/>
-            <a:ext cx="5584687" cy="5129212"/>
+            <a:off x="8732520" y="2240280"/>
+            <a:ext cx="3171139" cy="3108960"/>
           </a:xfrm>
         </p:spPr>
         <p:txBody>
@@ -2011,8 +2011,8 @@
         </p:nvSpPr>
         <p:spPr>
           <a:xfrm>
-            <a:off x="6173304" y="1088800"/>
-            <a:ext cx="5584687" cy="5128593"/>
+            <a:off x="4160520" y="1600200"/>
+            <a:ext cx="7680960" cy="4114800"/>
           </a:xfrm>
         </p:spPr>
         <p:txBody>
@@ -2203,8 +2203,8 @@
         </p:nvSpPr>
         <p:spPr>
           <a:xfrm>
-            <a:off x="317500" y="1088181"/>
-            <a:ext cx="5584687" cy="5129212"/>
+            <a:off x="452628" y="1874520"/>
+            <a:ext cx="3154680" cy="3108960"/>
           </a:xfrm>
         </p:spPr>
         <p:txBody>
@@ -2373,8 +2373,8 @@
         </p:nvSpPr>
         <p:spPr>
           <a:xfrm>
-            <a:off x="6173304" y="1088800"/>
-            <a:ext cx="5584687" cy="2458800"/>
+            <a:off x="4160520" y="1554480"/>
+            <a:ext cx="7743139" cy="1463040"/>
           </a:xfrm>
         </p:spPr>
         <p:txBody>
@@ -2565,8 +2565,8 @@
         </p:nvSpPr>
         <p:spPr>
           <a:xfrm>
-            <a:off x="317500" y="1088181"/>
-            <a:ext cx="5584687" cy="5129212"/>
+            <a:off x="452628" y="1874520"/>
+            <a:ext cx="3154680" cy="3291840"/>
           </a:xfrm>
         </p:spPr>
         <p:txBody>
@@ -2628,8 +2628,8 @@
         </p:nvSpPr>
         <p:spPr>
           <a:xfrm>
-            <a:off x="6173303" y="3758593"/>
-            <a:ext cx="5584687" cy="2458800"/>
+            <a:off x="4160520" y="3383280"/>
+            <a:ext cx="7743139" cy="2331720"/>
           </a:xfrm>
         </p:spPr>
         <p:txBody>
@@ -2765,8 +2765,8 @@
         </p:nvSpPr>
         <p:spPr>
           <a:xfrm>
-            <a:off x="317501" y="1103243"/>
-            <a:ext cx="5584687" cy="2455279"/>
+            <a:off x="452628" y="1554480"/>
+            <a:ext cx="7863840" cy="1737360"/>
           </a:xfrm>
         </p:spPr>
         <p:txBody>
@@ -2957,8 +2957,8 @@
         </p:nvSpPr>
         <p:spPr>
           <a:xfrm>
-            <a:off x="6173926" y="1103313"/>
-            <a:ext cx="5584687" cy="5129212"/>
+            <a:off x="8732520" y="1874520"/>
+            <a:ext cx="3171139" cy="3108960"/>
           </a:xfrm>
         </p:spPr>
         <p:txBody>
@@ -3020,8 +3020,8 @@
         </p:nvSpPr>
         <p:spPr>
           <a:xfrm>
-            <a:off x="317501" y="3747052"/>
-            <a:ext cx="5584687" cy="2455279"/>
+            <a:off x="452628" y="3474720"/>
+            <a:ext cx="7863840" cy="2240280"/>
           </a:xfrm>
         </p:spPr>
         <p:txBody>
@@ -15380,8 +15380,8 @@
         </p:nvSpPr>
         <p:spPr>
           <a:xfrm>
-            <a:off x="461464" y="1461329"/>
-            <a:ext cx="3650620" cy="1872000"/>
+            <a:off x="452628" y="1508760"/>
+            <a:ext cx="3573475" cy="2089404"/>
           </a:xfrm>
         </p:spPr>
         <p:txBody>
@@ -15413,8 +15413,8 @@
         </p:nvSpPr>
         <p:spPr>
           <a:xfrm>
-            <a:off x="1414524" y="4211584"/>
-            <a:ext cx="3650619" cy="1872000"/>
+            <a:off x="452628" y="3963924"/>
+            <a:ext cx="5360213" cy="1751076"/>
           </a:xfrm>
         </p:spPr>
         <p:txBody>
@@ -15443,8 +15443,8 @@
         </p:nvSpPr>
         <p:spPr>
           <a:xfrm>
-            <a:off x="8079916" y="1461329"/>
-            <a:ext cx="3594360" cy="1872000"/>
+            <a:off x="8330184" y="1508760"/>
+            <a:ext cx="3573475" cy="2089404"/>
           </a:xfrm>
         </p:spPr>
         <p:txBody>
@@ -15476,8 +15476,8 @@
         </p:nvSpPr>
         <p:spPr>
           <a:xfrm>
-            <a:off x="7126857" y="4201698"/>
-            <a:ext cx="3594362" cy="1872000"/>
+            <a:off x="6544361" y="3963010"/>
+            <a:ext cx="5360213" cy="1751076"/>
           </a:xfrm>
         </p:spPr>
         <p:txBody>
@@ -15587,8 +15587,8 @@
         </p:nvSpPr>
         <p:spPr>
           <a:xfrm>
-            <a:off x="4298820" y="1184305"/>
-            <a:ext cx="3594360" cy="1872000"/>
+            <a:off x="4391863" y="1507846"/>
+            <a:ext cx="3573475" cy="2089404"/>
           </a:xfrm>
         </p:spPr>
         <p:txBody>
@@ -15620,8 +15620,8 @@
         </p:nvSpPr>
         <p:spPr>
           <a:xfrm>
-            <a:off x="5227036" y="3153394"/>
-            <a:ext cx="1737928" cy="1738800"/>
+            <a:off x="452628" y="164592"/>
+            <a:ext cx="274320" cy="274320"/>
           </a:xfrm>
         </p:spPr>
         <p:txBody>
@@ -15982,8 +15982,8 @@
         </p:nvSpPr>
         <p:spPr>
           <a:xfrm>
-            <a:off x="461464" y="1461329"/>
-            <a:ext cx="3650620" cy="1872000"/>
+            <a:off x="452628" y="1508760"/>
+            <a:ext cx="3573475" cy="2011680"/>
           </a:xfrm>
         </p:spPr>
         <p:txBody>
@@ -16015,8 +16015,8 @@
         </p:nvSpPr>
         <p:spPr>
           <a:xfrm>
-            <a:off x="461465" y="4201698"/>
-            <a:ext cx="3650619" cy="1872000"/>
+            <a:off x="452628" y="4113886"/>
+            <a:ext cx="3573475" cy="1600200"/>
           </a:xfrm>
         </p:spPr>
         <p:txBody>
@@ -16045,8 +16045,8 @@
         </p:nvSpPr>
         <p:spPr>
           <a:xfrm>
-            <a:off x="8079916" y="1461329"/>
-            <a:ext cx="3594360" cy="1872000"/>
+            <a:off x="8330184" y="1508760"/>
+            <a:ext cx="3573475" cy="2011680"/>
           </a:xfrm>
         </p:spPr>
         <p:txBody>
@@ -16078,8 +16078,8 @@
         </p:nvSpPr>
         <p:spPr>
           <a:xfrm>
-            <a:off x="8079915" y="4199144"/>
-            <a:ext cx="3594362" cy="1872000"/>
+            <a:off x="8330184" y="4112971"/>
+            <a:ext cx="3573475" cy="1600200"/>
           </a:xfrm>
         </p:spPr>
         <p:txBody>
@@ -16189,8 +16189,8 @@
         </p:nvSpPr>
         <p:spPr>
           <a:xfrm>
-            <a:off x="4298820" y="1184305"/>
-            <a:ext cx="3594360" cy="1872000"/>
+            <a:off x="4391863" y="1507846"/>
+            <a:ext cx="3573475" cy="2011680"/>
           </a:xfrm>
         </p:spPr>
         <p:txBody>
@@ -16222,8 +16222,8 @@
         </p:nvSpPr>
         <p:spPr>
           <a:xfrm>
-            <a:off x="4298819" y="4435107"/>
-            <a:ext cx="3594360" cy="1872000"/>
+            <a:off x="4391863" y="4114800"/>
+            <a:ext cx="3573475" cy="1600200"/>
           </a:xfrm>
         </p:spPr>
         <p:txBody>
@@ -16255,8 +16255,8 @@
         </p:nvSpPr>
         <p:spPr>
           <a:xfrm>
-            <a:off x="5516217" y="3082608"/>
-            <a:ext cx="1386773" cy="1387469"/>
+            <a:off x="452628" y="164592"/>
+            <a:ext cx="274320" cy="274320"/>
           </a:xfrm>
         </p:spPr>
         <p:txBody>
@@ -20724,8 +20724,8 @@
         </p:nvSpPr>
         <p:spPr>
           <a:xfrm>
-            <a:off x="461772" y="1212494"/>
-            <a:ext cx="6949440" cy="4887468"/>
+            <a:off x="452628" y="1463040"/>
+            <a:ext cx="7680960" cy="4251960"/>
           </a:xfrm>
         </p:spPr>
         <p:txBody>
@@ -20757,8 +20757,8 @@
         </p:nvSpPr>
         <p:spPr>
           <a:xfrm>
-            <a:off x="7731252" y="1920240"/>
-            <a:ext cx="4114800" cy="3474720"/>
+            <a:off x="8549640" y="1463040"/>
+            <a:ext cx="3354019" cy="4251960"/>
           </a:xfrm>
         </p:spPr>
         <p:txBody>
@@ -21167,8 +21167,8 @@
         </p:nvSpPr>
         <p:spPr>
           <a:xfrm>
-            <a:off x="2011680" y="1212494"/>
-            <a:ext cx="9802368" cy="1417320"/>
+            <a:off x="452628" y="1508760"/>
+            <a:ext cx="11451031" cy="1078992"/>
           </a:xfrm>
         </p:spPr>
         <p:txBody>
@@ -21200,8 +21200,8 @@
         </p:nvSpPr>
         <p:spPr>
           <a:xfrm>
-            <a:off x="2011680" y="2926080"/>
-            <a:ext cx="9802368" cy="1417320"/>
+            <a:off x="452628" y="3044952"/>
+            <a:ext cx="11451031" cy="1078992"/>
           </a:xfrm>
         </p:spPr>
         <p:txBody>
@@ -21230,8 +21230,8 @@
         </p:nvSpPr>
         <p:spPr>
           <a:xfrm>
-            <a:off x="2011680" y="4663440"/>
-            <a:ext cx="9802368" cy="1417320"/>
+            <a:off x="452628" y="4581144"/>
+            <a:ext cx="11451031" cy="1133856"/>
           </a:xfrm>
         </p:spPr>
         <p:txBody>
@@ -21344,8 +21344,8 @@
         </p:nvSpPr>
         <p:spPr>
           <a:xfrm>
-            <a:off x="502920" y="2834640"/>
-            <a:ext cx="1234440" cy="1234440"/>
+            <a:off x="452628" y="164592"/>
+            <a:ext cx="274320" cy="274320"/>
           </a:xfrm>
         </p:spPr>
         <p:txBody>

</xml_diff>